<commit_message>
feat: harden DevFlow finals release candidate
</commit_message>
<xml_diff>
--- a/outputs/DevFlow_GOAI_2026_初赛方案_20260728.pptx
+++ b/outputs/DevFlow_GOAI_2026_初赛方案_20260728.pptx
@@ -2,24 +2,24 @@
 <file path=ppt/presentation.xml><?xml version="1.0" encoding="utf-8"?>
 <p:presentation xmlns:p="http://schemas.openxmlformats.org/presentationml/2006/main">
   <p:sldMasterIdLst>
-    <p:sldMasterId xmlns:r="http://schemas.openxmlformats.org/officeDocument/2006/relationships" id="2147483648" r:id="Re22cc72968254c59"/>
+    <p:sldMasterId xmlns:r="http://schemas.openxmlformats.org/officeDocument/2006/relationships" id="2147483648" r:id="Rb0e6ea7f93cc492b"/>
   </p:sldMasterIdLst>
   <p:notesMasterIdLst>
-    <p:notesMasterId xmlns:r="http://schemas.openxmlformats.org/officeDocument/2006/relationships" r:id="Re54251fbf30d453c"/>
+    <p:notesMasterId xmlns:r="http://schemas.openxmlformats.org/officeDocument/2006/relationships" r:id="R242423f97e494113"/>
   </p:notesMasterIdLst>
   <p:sldIdLst>
-    <p:sldId xmlns:r="http://schemas.openxmlformats.org/officeDocument/2006/relationships" id="256" r:id="R814cf8a12c1f4314"/>
-    <p:sldId xmlns:r="http://schemas.openxmlformats.org/officeDocument/2006/relationships" id="257" r:id="R825ab13cf3f24802"/>
-    <p:sldId xmlns:r="http://schemas.openxmlformats.org/officeDocument/2006/relationships" id="258" r:id="R2d92c21bad024edd"/>
-    <p:sldId xmlns:r="http://schemas.openxmlformats.org/officeDocument/2006/relationships" id="259" r:id="R9345f8d27e7f41a6"/>
-    <p:sldId xmlns:r="http://schemas.openxmlformats.org/officeDocument/2006/relationships" id="260" r:id="R4c53a67e16bf458d"/>
-    <p:sldId xmlns:r="http://schemas.openxmlformats.org/officeDocument/2006/relationships" id="261" r:id="R4d6289babdce490a"/>
-    <p:sldId xmlns:r="http://schemas.openxmlformats.org/officeDocument/2006/relationships" id="262" r:id="Re1b5314106a04455"/>
-    <p:sldId xmlns:r="http://schemas.openxmlformats.org/officeDocument/2006/relationships" id="263" r:id="R147f26c3441f414f"/>
-    <p:sldId xmlns:r="http://schemas.openxmlformats.org/officeDocument/2006/relationships" id="264" r:id="R01b1685c84074f72"/>
-    <p:sldId xmlns:r="http://schemas.openxmlformats.org/officeDocument/2006/relationships" id="265" r:id="R0f3937db604a4f02"/>
-    <p:sldId xmlns:r="http://schemas.openxmlformats.org/officeDocument/2006/relationships" id="266" r:id="R20bc87a76a634a6c"/>
-    <p:sldId xmlns:r="http://schemas.openxmlformats.org/officeDocument/2006/relationships" id="267" r:id="R8d42a9638b6a4431"/>
+    <p:sldId xmlns:r="http://schemas.openxmlformats.org/officeDocument/2006/relationships" id="256" r:id="Rcbf8837ec886435b"/>
+    <p:sldId xmlns:r="http://schemas.openxmlformats.org/officeDocument/2006/relationships" id="257" r:id="R40c82056a8fc491f"/>
+    <p:sldId xmlns:r="http://schemas.openxmlformats.org/officeDocument/2006/relationships" id="258" r:id="R957c35097dc94c02"/>
+    <p:sldId xmlns:r="http://schemas.openxmlformats.org/officeDocument/2006/relationships" id="259" r:id="R390e264b6f774475"/>
+    <p:sldId xmlns:r="http://schemas.openxmlformats.org/officeDocument/2006/relationships" id="260" r:id="Re87b9662b581413f"/>
+    <p:sldId xmlns:r="http://schemas.openxmlformats.org/officeDocument/2006/relationships" id="261" r:id="R19b42d03deea47f7"/>
+    <p:sldId xmlns:r="http://schemas.openxmlformats.org/officeDocument/2006/relationships" id="262" r:id="Rd71532aa6dbe40be"/>
+    <p:sldId xmlns:r="http://schemas.openxmlformats.org/officeDocument/2006/relationships" id="263" r:id="R67bc30eb524f45ae"/>
+    <p:sldId xmlns:r="http://schemas.openxmlformats.org/officeDocument/2006/relationships" id="264" r:id="R94c1000ef9f04a6b"/>
+    <p:sldId xmlns:r="http://schemas.openxmlformats.org/officeDocument/2006/relationships" id="265" r:id="R64bb83a8970f48a9"/>
+    <p:sldId xmlns:r="http://schemas.openxmlformats.org/officeDocument/2006/relationships" id="266" r:id="Rf35b873966054419"/>
+    <p:sldId xmlns:r="http://schemas.openxmlformats.org/officeDocument/2006/relationships" id="267" r:id="Rb654c416e4114323"/>
   </p:sldIdLst>
   <p:sldSz cx="12192000" cy="6858000"/>
   <p:notesSz cx="6858000" cy="9144000"/>
@@ -1038,22 +1038,22 @@
           <a:lstStyle xmlns:a="http://schemas.openxmlformats.org/drawingml/2006/main"/>
           <a:p xmlns:a="http://schemas.openxmlformats.org/drawingml/2006/main">
             <a:r>
+              <a:t>本页逐项对应官方五项核验：角色编排、任务拆解、上下文传递、协同执行与状态追踪。Manager、Team、Worker、Team Room、Worker Room、project/taskflow、assignment/ACK/result/readback 属于 AgentTeams 设计基点；Handoff 摘要绑定、持久账本和精确人工批准是 DevFlow 的有界安全扩展。</a:t>
+            </a:r>
+          </a:p>
+          <a:p xmlns:a="http://schemas.openxmlformats.org/drawingml/2006/main">
+            <a:r>
               <a:t>[Sources]</a:t>
             </a:r>
           </a:p>
           <a:p xmlns:a="http://schemas.openxmlformats.org/drawingml/2006/main">
             <a:r>
-              <a:t>- docs/AGENTTEAMS.md:98-107</a:t>
-            </a:r>
-          </a:p>
-          <a:p xmlns:a="http://schemas.openxmlformats.org/drawingml/2006/main">
-            <a:r>
-              <a:t>- docs/submission/AGENT_IDENTITY_APPENDIX.md:18-28</a:t>
-            </a:r>
-          </a:p>
-          <a:p xmlns:a="http://schemas.openxmlformats.org/drawingml/2006/main">
-            <a:r>
-              <a:t>- docs/evidence/AGENTTEAMS_LIVE_20260727.md:60-92（仅两节点实证）</a:t>
+              <a:t>- https://www.goaihz.com/tracks?track=infra（访问 2026-07-28）</a:t>
+            </a:r>
+          </a:p>
+          <a:p xmlns:a="http://schemas.openxmlformats.org/drawingml/2006/main">
+            <a:r>
+              <a:t>- docs/submission/AGENTTEAMS_MAPPING_CN.md</a:t>
             </a:r>
           </a:p>
         </p:txBody>
@@ -1461,7 +1461,7 @@
   </p:cSld>
   <p:clrMap bg1="lt1" tx1="dk1" bg2="lt2" tx2="dk2" accent1="accent1" accent2="accent2" accent3="accent3" accent4="accent4" accent5="accent5" accent6="accent6" hlink="hlink" folHlink="folHlink"/>
   <p:sldLayoutIdLst>
-    <p:sldLayoutId xmlns:r="http://schemas.openxmlformats.org/officeDocument/2006/relationships" id="2147483649" r:id="R4793dc6fc71c416e"/>
+    <p:sldLayoutId xmlns:r="http://schemas.openxmlformats.org/officeDocument/2006/relationships" id="2147483649" r:id="R3b025ea0a400457d"/>
   </p:sldLayoutIdLst>
   <p:txStyles>
     <p:titleStyle>
@@ -2744,7 +2744,7 @@
       </p:sp>
       <p:cxnSp>
         <p:nvCxnSpPr>
-          <p:cNvPr id="27" name="Google-Shape-2259-p159-4"/>
+          <p:cNvPr id="30" name="Google-Shape-2259-p159-4"/>
           <p:cNvCxnSpPr/>
           <p:nvPr/>
         </p:nvCxnSpPr>
@@ -5757,14 +5757,14 @@
                 <a:ea typeface="Noto Sans SC"/>
                 <a:cs typeface="Noto Sans SC"/>
               </a:rPr>
-              <a:t>TeamHarness 将“协作”约束成有状态协议</a:t>
+              <a:t>AgentTeams 五项硬映射：从框架对象到协作语义</a:t>
             </a:r>
           </a:p>
         </p:txBody>
       </p:sp>
       <p:cxnSp>
         <p:nvCxnSpPr>
-          <p:cNvPr id="27" name="Google-Shape-2259-p159-4"/>
+          <p:cNvPr id="30" name="Google-Shape-2259-p159-4"/>
           <p:cNvCxnSpPr/>
           <p:nvPr/>
         </p:nvCxnSpPr>
@@ -5923,7 +5923,7 @@
                 <a:ea typeface="Noto Sans SC"/>
                 <a:cs typeface="Noto Sans SC"/>
               </a:rPr>
-              <a:t>ASSIGN / ACK</a:t>
+              <a:t>ROLE / TASK</a:t>
             </a:r>
           </a:p>
         </p:txBody>
@@ -5986,7 +5986,7 @@
                 <a:ea typeface="Noto Sans SC"/>
                 <a:cs typeface="Noto Sans SC"/>
               </a:rPr>
-              <a:t>SUBMIT / ACCEPT</a:t>
+              <a:t>CONTEXT / RUN</a:t>
             </a:r>
           </a:p>
         </p:txBody>
@@ -6049,7 +6049,7 @@
                 <a:ea typeface="Noto Sans SC"/>
                 <a:cs typeface="Noto Sans SC"/>
               </a:rPr>
-              <a:t>REPORT / READBACK</a:t>
+              <a:t>STATE / TRACK</a:t>
             </a:r>
           </a:p>
         </p:txBody>
@@ -6112,7 +6112,7 @@
                 <a:ea typeface="Noto Sans SC"/>
                 <a:cs typeface="Noto Sans SC"/>
               </a:rPr>
-              <a:t>摘要不漂移</a:t>
+              <a:t>上下文传递与协同执行</a:t>
             </a:r>
           </a:p>
           <a:p xmlns:a="http://schemas.openxmlformats.org/drawingml/2006/main">
@@ -6145,18 +6145,7 @@
                 <a:ea typeface="Noto Sans SC"/>
                 <a:cs typeface="Noto Sans SC"/>
               </a:rPr>
-              <a:t>同 assignment 重试必须保持同一摘要；不同摘要直接冲突失败。</a:t>
-            </a:r>
-            <a:r>
-              <a:rPr sz="1350">
-                <a:solidFill>
-                  <a:srgbClr val="262626"/>
-                </a:solidFill>
-                <a:latin typeface="Noto Sans SC"/>
-                <a:ea typeface="Noto Sans SC"/>
-                <a:cs typeface="Noto Sans SC"/>
-              </a:rPr>
-              <a:t>红测经 Leader 转发脱敏、有界证据。</a:t>
+              <a:t>Team Room 共享状态；Worker Room 保持最小上下文；Handoff 验后只调用所属 Skill。</a:t>
             </a:r>
           </a:p>
         </p:txBody>
@@ -6219,7 +6208,7 @@
                 <a:ea typeface="Noto Sans SC"/>
                 <a:cs typeface="Noto Sans SC"/>
               </a:rPr>
-              <a:t>风险先冻结</a:t>
+              <a:t>角色编排与任务拆解</a:t>
             </a:r>
           </a:p>
           <a:p xmlns:a="http://schemas.openxmlformats.org/drawingml/2006/main">
@@ -6252,7 +6241,7 @@
                 <a:ea typeface="Noto Sans SC"/>
                 <a:cs typeface="Noto Sans SC"/>
               </a:rPr>
-              <a:t>Leader 固定 T1–T5；有界 assignment。Worker 只对自己的任务幂等 ACK。</a:t>
+              <a:t>Manager 建 Team；Leader 拆 DAG 并定向 assignment；Worker 只 ACK 自己任务。</a:t>
             </a:r>
           </a:p>
         </p:txBody>
@@ -6315,7 +6304,7 @@
                 <a:ea typeface="Noto Sans SC"/>
                 <a:cs typeface="Noto Sans SC"/>
               </a:rPr>
-              <a:t>完成要读回</a:t>
+              <a:t>状态追踪</a:t>
             </a:r>
           </a:p>
           <a:p xmlns:a="http://schemas.openxmlformats.org/drawingml/2006/main">
@@ -6348,7 +6337,7 @@
                 <a:ea typeface="Noto Sans SC"/>
                 <a:cs typeface="Noto Sans SC"/>
               </a:rPr>
-              <a:t>mark → push → pending=false。T4/T5 设计要求外部 Ed25519 批准；真人闭环尚待实证。</a:t>
+              <a:t>taskflow 跟踪 ACK/结果/验收；readback 完成，失败 retry，高风险 PAUSED。</a:t>
             </a:r>
           </a:p>
         </p:txBody>

</xml_diff>